<commit_message>
Use prompt density review for deck skill
</commit_message>
<xml_diff>
--- a/sample_source_deck.pptx
+++ b/sample_source_deck.pptx
@@ -4844,7 +4844,7 @@
           </a:bodyPr>
           <a:lstStyle/>
           <a:p>
-            <a:fld id="{308E40AE-4C6B-4C57-85E7-366E3BBE311E}" type="slidenum">
+            <a:fld id="{B42C579C-2DB6-4B07-B6E0-4A2C88428FE3}" type="slidenum">
               <a:rPr lang="ja-JP" smtClean="0" sz="1000">
                 <a:solidFill>
                   <a:srgbClr val="888888"/>
@@ -4860,7 +4860,7 @@
               </a:rPr>
               <a:t>/</a:t>
             </a:r>
-            <a:fld id="{F9E01EFF-D4AA-4DAD-8A99-23CCDE3F92DA}" type="slidecount">
+            <a:fld id="{9D490F3B-078A-44E6-9562-ADD0C5ACADB2}" type="slidecount">
               <a:rPr lang="ja-JP" smtClean="0" sz="1000">
                 <a:solidFill>
                   <a:srgbClr val="888888"/>
@@ -5942,7 +5942,7 @@
           </a:bodyPr>
           <a:lstStyle/>
           <a:p>
-            <a:fld id="{CF0A406C-420E-42F0-8F91-76A519798F74}" type="slidenum">
+            <a:fld id="{F1FDB997-4E0A-4BC1-8344-3E8132476FCD}" type="slidenum">
               <a:rPr lang="ja-JP" smtClean="0" sz="1000">
                 <a:solidFill>
                   <a:srgbClr val="888888"/>
@@ -5958,7 +5958,7 @@
               </a:rPr>
               <a:t>/</a:t>
             </a:r>
-            <a:fld id="{2D624AA9-B0F7-4EFC-952B-28B1AC855147}" type="slidecount">
+            <a:fld id="{E72A7138-FC6F-490B-A13F-CA5046CAFEBF}" type="slidecount">
               <a:rPr lang="ja-JP" smtClean="0" sz="1000">
                 <a:solidFill>
                   <a:srgbClr val="888888"/>
@@ -7430,7 +7430,7 @@
           </a:bodyPr>
           <a:lstStyle/>
           <a:p>
-            <a:fld id="{090C780C-B376-499B-813A-3DA04D6C6DA7}" type="slidenum">
+            <a:fld id="{48C8594B-4E0E-498C-835A-0A4050735DFB}" type="slidenum">
               <a:rPr lang="ja-JP" smtClean="0" sz="1000">
                 <a:solidFill>
                   <a:srgbClr val="888888"/>
@@ -7446,7 +7446,7 @@
               </a:rPr>
               <a:t>/</a:t>
             </a:r>
-            <a:fld id="{8F6E9E1E-48FD-4C79-9629-EDF938FD2642}" type="slidecount">
+            <a:fld id="{9728A10C-79C2-4DC9-8A02-73A7A16E3030}" type="slidecount">
               <a:rPr lang="ja-JP" smtClean="0" sz="1000">
                 <a:solidFill>
                   <a:srgbClr val="888888"/>
@@ -8873,7 +8873,7 @@
           </a:bodyPr>
           <a:lstStyle/>
           <a:p>
-            <a:fld id="{259A97EB-62E1-4634-B9BB-41CC8641DE67}" type="slidenum">
+            <a:fld id="{10F7C78E-D47C-4F5C-837B-BEABF63BA0AD}" type="slidenum">
               <a:rPr lang="ja-JP" smtClean="0" sz="1000">
                 <a:solidFill>
                   <a:srgbClr val="888888"/>
@@ -8889,7 +8889,7 @@
               </a:rPr>
               <a:t>/</a:t>
             </a:r>
-            <a:fld id="{A44305B1-0190-4718-BE6E-655BA99957A6}" type="slidecount">
+            <a:fld id="{C9296D4A-A46B-4DB1-BA40-3DD9304C8572}" type="slidecount">
               <a:rPr lang="ja-JP" smtClean="0" sz="1000">
                 <a:solidFill>
                   <a:srgbClr val="888888"/>
@@ -9860,7 +9860,7 @@
           </a:bodyPr>
           <a:lstStyle/>
           <a:p>
-            <a:fld id="{3232773E-72C2-4FAA-AF85-19D04E970FC7}" type="slidenum">
+            <a:fld id="{82219CED-64C4-4F27-A917-E299F0943A35}" type="slidenum">
               <a:rPr lang="ja-JP" smtClean="0" sz="1000">
                 <a:solidFill>
                   <a:srgbClr val="888888"/>
@@ -9876,7 +9876,7 @@
               </a:rPr>
               <a:t>/</a:t>
             </a:r>
-            <a:fld id="{5EB768F3-2FE6-4CA3-A21C-33B76D765858}" type="slidecount">
+            <a:fld id="{655B885D-E548-404B-B672-94C852E73A0C}" type="slidecount">
               <a:rPr lang="ja-JP" smtClean="0" sz="1000">
                 <a:solidFill>
                   <a:srgbClr val="888888"/>
@@ -10967,7 +10967,7 @@
           </a:bodyPr>
           <a:lstStyle/>
           <a:p>
-            <a:fld id="{D6458B6D-791E-45A4-A0AD-9980E2FF8DB1}" type="slidenum">
+            <a:fld id="{FFD3687F-4B5B-4B15-BB91-24C7B043A4FE}" type="slidenum">
               <a:rPr lang="ja-JP" smtClean="0" sz="1000">
                 <a:solidFill>
                   <a:srgbClr val="888888"/>
@@ -10983,7 +10983,7 @@
               </a:rPr>
               <a:t>/</a:t>
             </a:r>
-            <a:fld id="{A36A1B85-6C23-4C21-ABE6-526A51068267}" type="slidecount">
+            <a:fld id="{3EE62949-C97D-4F17-9E00-5EEDAD582DD6}" type="slidecount">
               <a:rPr lang="ja-JP" smtClean="0" sz="1000">
                 <a:solidFill>
                   <a:srgbClr val="888888"/>
@@ -11963,7 +11963,7 @@
           </a:bodyPr>
           <a:lstStyle/>
           <a:p>
-            <a:fld id="{599AD999-4A74-48F7-90A8-E2264A8B3303}" type="slidenum">
+            <a:fld id="{6AAB20C8-9BC5-4D27-87F3-B15F6CC9335B}" type="slidenum">
               <a:rPr lang="ja-JP" smtClean="0" sz="1000">
                 <a:solidFill>
                   <a:srgbClr val="888888"/>
@@ -11979,7 +11979,7 @@
               </a:rPr>
               <a:t>/</a:t>
             </a:r>
-            <a:fld id="{83E5444C-8D76-417B-ADBD-D2F295811C05}" type="slidecount">
+            <a:fld id="{4AE8CF79-B57F-45BF-A3CB-FDC90F6D930F}" type="slidecount">
               <a:rPr lang="ja-JP" smtClean="0" sz="1000">
                 <a:solidFill>
                   <a:srgbClr val="888888"/>
@@ -13121,7 +13121,7 @@
           </a:bodyPr>
           <a:lstStyle/>
           <a:p>
-            <a:fld id="{30E3AC02-E3BA-432F-BFE1-2B6CB6AF535F}" type="slidenum">
+            <a:fld id="{7155BB6A-7694-4A31-8BE4-2388199C512B}" type="slidenum">
               <a:rPr lang="ja-JP" smtClean="0" sz="1000">
                 <a:solidFill>
                   <a:srgbClr val="888888"/>
@@ -13137,7 +13137,7 @@
               </a:rPr>
               <a:t>/</a:t>
             </a:r>
-            <a:fld id="{70E1910F-8B76-4973-AA53-AF7262529E4B}" type="slidecount">
+            <a:fld id="{498C620D-C832-4E0D-9359-B8F0F5FAB669}" type="slidecount">
               <a:rPr lang="ja-JP" smtClean="0" sz="1000">
                 <a:solidFill>
                   <a:srgbClr val="888888"/>

</xml_diff>